<commit_message>
Apply equal day and night consumption split to juice shop presentation
</commit_message>
<xml_diff>
--- a/El_Mo3alem_Juice_Shop_Solar_BESS.pptx
+++ b/El_Mo3alem_Juice_Shop_Solar_BESS.pptx
@@ -2,24 +2,24 @@
 <file path=ppt/presentation.xml><?xml version="1.0" encoding="utf-8"?>
 <p:presentation xmlns:p="http://schemas.openxmlformats.org/presentationml/2006/main">
   <p:sldMasterIdLst>
-    <p:sldMasterId xmlns:r="http://schemas.openxmlformats.org/officeDocument/2006/relationships" id="2147483648" r:id="R6fc5aa1166784134"/>
+    <p:sldMasterId xmlns:r="http://schemas.openxmlformats.org/officeDocument/2006/relationships" id="2147483648" r:id="R52635925e8d04ecc"/>
   </p:sldMasterIdLst>
   <p:notesMasterIdLst>
-    <p:notesMasterId xmlns:r="http://schemas.openxmlformats.org/officeDocument/2006/relationships" r:id="R19801abdbbaa4fcf"/>
+    <p:notesMasterId xmlns:r="http://schemas.openxmlformats.org/officeDocument/2006/relationships" r:id="R987a6bc1003a4714"/>
   </p:notesMasterIdLst>
   <p:sldIdLst>
-    <p:sldId xmlns:r="http://schemas.openxmlformats.org/officeDocument/2006/relationships" id="256" r:id="Rcb5dc5f3e16c4020"/>
-    <p:sldId xmlns:r="http://schemas.openxmlformats.org/officeDocument/2006/relationships" id="257" r:id="Rdd06630c79a0479a"/>
-    <p:sldId xmlns:r="http://schemas.openxmlformats.org/officeDocument/2006/relationships" id="258" r:id="R0b5164a99476456d"/>
-    <p:sldId xmlns:r="http://schemas.openxmlformats.org/officeDocument/2006/relationships" id="259" r:id="R78a1dba513254af1"/>
-    <p:sldId xmlns:r="http://schemas.openxmlformats.org/officeDocument/2006/relationships" id="260" r:id="R7f4c721786a34b07"/>
-    <p:sldId xmlns:r="http://schemas.openxmlformats.org/officeDocument/2006/relationships" id="261" r:id="R6c3386a1a9ec43e9"/>
-    <p:sldId xmlns:r="http://schemas.openxmlformats.org/officeDocument/2006/relationships" id="262" r:id="Rc83457ef6e614ed2"/>
-    <p:sldId xmlns:r="http://schemas.openxmlformats.org/officeDocument/2006/relationships" id="263" r:id="R7d5fcc3751604371"/>
-    <p:sldId xmlns:r="http://schemas.openxmlformats.org/officeDocument/2006/relationships" id="264" r:id="R706c60ce63174e8d"/>
-    <p:sldId xmlns:r="http://schemas.openxmlformats.org/officeDocument/2006/relationships" id="265" r:id="R2ef6a769f0424bc3"/>
-    <p:sldId xmlns:r="http://schemas.openxmlformats.org/officeDocument/2006/relationships" id="266" r:id="Rae27e19024bf49b8"/>
-    <p:sldId xmlns:r="http://schemas.openxmlformats.org/officeDocument/2006/relationships" id="267" r:id="R6d9bb0caf0e84c3c"/>
+    <p:sldId xmlns:r="http://schemas.openxmlformats.org/officeDocument/2006/relationships" id="256" r:id="Rd1dbfa975acf444e"/>
+    <p:sldId xmlns:r="http://schemas.openxmlformats.org/officeDocument/2006/relationships" id="257" r:id="Rd79c317041914a19"/>
+    <p:sldId xmlns:r="http://schemas.openxmlformats.org/officeDocument/2006/relationships" id="258" r:id="R54f2e97a2dc8438c"/>
+    <p:sldId xmlns:r="http://schemas.openxmlformats.org/officeDocument/2006/relationships" id="259" r:id="R130763a409394a65"/>
+    <p:sldId xmlns:r="http://schemas.openxmlformats.org/officeDocument/2006/relationships" id="260" r:id="R52d3f099c99b4d36"/>
+    <p:sldId xmlns:r="http://schemas.openxmlformats.org/officeDocument/2006/relationships" id="261" r:id="R2c1cb99ae03d4d55"/>
+    <p:sldId xmlns:r="http://schemas.openxmlformats.org/officeDocument/2006/relationships" id="262" r:id="Rdefba6fa3ae04b95"/>
+    <p:sldId xmlns:r="http://schemas.openxmlformats.org/officeDocument/2006/relationships" id="263" r:id="R71c35853d284465d"/>
+    <p:sldId xmlns:r="http://schemas.openxmlformats.org/officeDocument/2006/relationships" id="264" r:id="Rae2279b887674205"/>
+    <p:sldId xmlns:r="http://schemas.openxmlformats.org/officeDocument/2006/relationships" id="265" r:id="Rbecfdf7582fb4d44"/>
+    <p:sldId xmlns:r="http://schemas.openxmlformats.org/officeDocument/2006/relationships" id="266" r:id="R954f3a4dcf374c16"/>
+    <p:sldId xmlns:r="http://schemas.openxmlformats.org/officeDocument/2006/relationships" id="267" r:id="Rd01404ed01384730"/>
   </p:sldIdLst>
   <p:sldSz cx="12192000" cy="6858000"/>
   <p:notesSz cx="6858000" cy="9144000"/>
@@ -474,7 +474,16 @@
         <p:txBody>
           <a:bodyPr xmlns:a="http://schemas.openxmlformats.org/drawingml/2006/main"/>
           <a:lstStyle xmlns:a="http://schemas.openxmlformats.org/drawingml/2006/main"/>
-          <a:p xmlns:a="http://schemas.openxmlformats.org/drawingml/2006/main"/>
+          <a:p xmlns:a="http://schemas.openxmlformats.org/drawingml/2006/main">
+            <a:r>
+              <a:t>Day/night split set to 50%/50% by user request on 30 September 2026. Scenario assumption, not measured. E=80.7, D=N=40.35 kWh/day. Required whole-night nameplate capacity=40.35/(0.8*0.95)=53.0921 kWh. Option C retains the two-LV_32 (64 kWh) stack for the comparison. The existing battery efficiency convention remains preliminary; this update changes the consumption split only.</a:t>
+            </a:r>
+          </a:p>
+          <a:p xmlns:a="http://schemas.openxmlformats.org/drawingml/2006/main">
+            <a:r>
+              <a:t>Equipment inventory estimate totals 66.1 kWh/day; meter-based baseline 80.7 kWh/day is used. The former 58% inferred split is superseded.</a:t>
+            </a:r>
+          </a:p>
         </p:txBody>
       </p:sp>
       <p:sp>
@@ -542,6 +551,11 @@
           <a:lstStyle xmlns:a="http://schemas.openxmlformats.org/drawingml/2006/main"/>
           <a:p xmlns:a="http://schemas.openxmlformats.org/drawingml/2006/main">
             <a:r>
+              <a:t>Day/night split set to 50%/50% by user request on 30 September 2026. Scenario assumption, not measured. E=80.7, D=N=40.35 kWh/day. Required whole-night nameplate capacity=40.35/(0.8*0.95)=53.0921 kWh. Option C retains the two-LV_32 (64 kWh) stack for the comparison. The existing battery efficiency convention remains preliminary; this update changes the consumption split only.</a:t>
+            </a:r>
+          </a:p>
+          <a:p xmlns:a="http://schemas.openxmlformats.org/drawingml/2006/main">
+            <a:r>
               <a:t>Source: European Commission JRC PVGIS 5.3, retrieved 30 September 2026. https://re.jrc.ec.europa.eu/api/v5_3/PVcalc?lat=30.0444&amp;lon=31.2357&amp;peakpower=1&amp;loss=14&amp;angle=30&amp;aspect=0&amp;pvtechchoice=crystSi&amp;mountingplace=free&amp;outputformat=json</a:t>
             </a:r>
           </a:p>
@@ -552,7 +566,7 @@
           </a:p>
           <a:p xmlns:a="http://schemas.openxmlformats.org/drawingml/2006/main">
             <a:r>
-              <a:t>Recalculated using Y=4.98 and the existing 58% night-share scenario. Monthly saving remains an average-day illustration, not a twelve-month hourly simulation. Battery discharge losses require a separate model correction.</a:t>
+              <a:t>Recalculated scenarios: [{"C":0,"U":0,"P":8.5,"inv":10,"G":42.330000000000005,"direct":40.35,"battery":0,"M":1210.5,"newbill":3453.61,"saving":3413.61,"price":140800,"payback":3.4372213970937904},{"C":16,"U":12.8,"P":11,"inv":12,"G":54.78,"direct":40.35,"battery":12.8,"M":826.5,"newbill":2254.405,"saving":4612.8150000000005,"price":394240,"payback":7.12218750011291},{"C":64,"U":51.2,"P":17,"inv":20,"G":84.66000000000001,"direct":40.35,"battery":40.35,"M":0,"newbill":9,"saving":6858.22,"price":1154560,"payback":14.028907403573132}]</a:t>
             </a:r>
           </a:p>
         </p:txBody>
@@ -622,12 +636,22 @@
           <a:lstStyle xmlns:a="http://schemas.openxmlformats.org/drawingml/2006/main"/>
           <a:p xmlns:a="http://schemas.openxmlformats.org/drawingml/2006/main">
             <a:r>
+              <a:t>Day/night split set to 50%/50% by user request on 30 September 2026. Scenario assumption, not measured. E=80.7, D=N=40.35 kWh/day. Required whole-night nameplate capacity=40.35/(0.8*0.95)=53.0921 kWh. Option C retains the two-LV_32 (64 kWh) stack for the comparison. The existing battery efficiency convention remains preliminary; this update changes the consumption split only.</a:t>
+            </a:r>
+          </a:p>
+          <a:p xmlns:a="http://schemas.openxmlformats.org/drawingml/2006/main">
+            <a:r>
               <a:t>Source: European Commission JRC PVGIS 5.3, retrieved 30 September 2026. https://re.jrc.ec.europa.eu/api/v5_3/PVcalc?lat=30.0444&amp;lon=31.2357&amp;peakpower=1&amp;loss=14&amp;angle=30&amp;aspect=0&amp;pvtechchoice=crystSi&amp;mountingplace=free&amp;outputformat=json</a:t>
             </a:r>
           </a:p>
           <a:p xmlns:a="http://schemas.openxmlformats.org/drawingml/2006/main">
             <a:r>
               <a:t>PVGIS-SARAH3 / ERA5, 2005-2023. Cairo reference location 30.0444 N, 31.2357 E; 1 kWp crystalline silicon; fixed south-facing, 30-degree tilt, free-standing; user-entered system loss 14%. This is modeled PV electricity output, not irradiance or a site measurement. Local rooftop shading is not surveyed. Existing battery efficiency convention remains preliminary and needs harmonization before a customer quote.</a:t>
+            </a:r>
+          </a:p>
+          <a:p xmlns:a="http://schemas.openxmlformats.org/drawingml/2006/main">
+            <a:r>
+              <a:t>Recalculated scenarios: [{"C":0,"U":0,"P":8.5,"inv":10,"G":42.330000000000005,"direct":40.35,"battery":0,"M":1210.5,"newbill":3453.61,"saving":3413.61,"price":140800,"payback":3.4372213970937904},{"C":16,"U":12.8,"P":11,"inv":12,"G":54.78,"direct":40.35,"battery":12.8,"M":826.5,"newbill":2254.405,"saving":4612.8150000000005,"price":394240,"payback":7.12218750011291},{"C":64,"U":51.2,"P":17,"inv":20,"G":84.66000000000001,"direct":40.35,"battery":40.35,"M":0,"newbill":9,"saving":6858.22,"price":1154560,"payback":14.028907403573132}]</a:t>
             </a:r>
           </a:p>
         </p:txBody>
@@ -697,12 +721,22 @@
           <a:lstStyle xmlns:a="http://schemas.openxmlformats.org/drawingml/2006/main"/>
           <a:p xmlns:a="http://schemas.openxmlformats.org/drawingml/2006/main">
             <a:r>
+              <a:t>Day/night split set to 50%/50% by user request on 30 September 2026. Scenario assumption, not measured. E=80.7, D=N=40.35 kWh/day. Required whole-night nameplate capacity=40.35/(0.8*0.95)=53.0921 kWh. Option C retains the two-LV_32 (64 kWh) stack for the comparison. The existing battery efficiency convention remains preliminary; this update changes the consumption split only.</a:t>
+            </a:r>
+          </a:p>
+          <a:p xmlns:a="http://schemas.openxmlformats.org/drawingml/2006/main">
+            <a:r>
               <a:t>Source: European Commission JRC PVGIS 5.3, retrieved 30 September 2026. https://re.jrc.ec.europa.eu/api/v5_3/PVcalc?lat=30.0444&amp;lon=31.2357&amp;peakpower=1&amp;loss=14&amp;angle=30&amp;aspect=0&amp;pvtechchoice=crystSi&amp;mountingplace=free&amp;outputformat=json</a:t>
             </a:r>
           </a:p>
           <a:p xmlns:a="http://schemas.openxmlformats.org/drawingml/2006/main">
             <a:r>
               <a:t>PVGIS-SARAH3 / ERA5, 2005-2023. Cairo reference location 30.0444 N, 31.2357 E; 1 kWp crystalline silicon; fixed south-facing, 30-degree tilt, free-standing; user-entered system loss 14%. This is modeled PV electricity output, not irradiance or a site measurement. Local rooftop shading is not surveyed. Existing battery efficiency convention remains preliminary and needs harmonization before a customer quote.</a:t>
+            </a:r>
+          </a:p>
+          <a:p xmlns:a="http://schemas.openxmlformats.org/drawingml/2006/main">
+            <a:r>
+              <a:t>Recalculated scenarios: [{"C":0,"U":0,"P":8.5,"inv":10,"G":42.330000000000005,"direct":40.35,"battery":0,"M":1210.5,"newbill":3453.61,"saving":3413.61,"price":140800,"payback":3.4372213970937904},{"C":16,"U":12.8,"P":11,"inv":12,"G":54.78,"direct":40.35,"battery":12.8,"M":826.5,"newbill":2254.405,"saving":4612.8150000000005,"price":394240,"payback":7.12218750011291},{"C":64,"U":51.2,"P":17,"inv":20,"G":84.66000000000001,"direct":40.35,"battery":40.35,"M":0,"newbill":9,"saving":6858.22,"price":1154560,"payback":14.028907403573132}]</a:t>
             </a:r>
           </a:p>
         </p:txBody>
@@ -772,12 +806,22 @@
           <a:lstStyle xmlns:a="http://schemas.openxmlformats.org/drawingml/2006/main"/>
           <a:p xmlns:a="http://schemas.openxmlformats.org/drawingml/2006/main">
             <a:r>
-              <a:t>Equipment estimate from the site report totals 66.1 kWh/day against 80.7 kWh/day on the meter; the meter figure is used.</a:t>
-            </a:r>
-          </a:p>
-          <a:p xmlns:a="http://schemas.openxmlformats.org/drawingml/2006/main">
-            <a:r>
-              <a:t>Night share: refrigeration 42.4 x 14/24 + lights 4.5 x 8/15 + juicing 19.2 x 60% = 38.7 of 66.1 kWh = 58%.</a:t>
+              <a:t>Day/night split set to 50%/50% by user request on 30 September 2026. Scenario assumption, not measured. E=80.7, D=N=40.35 kWh/day. Required whole-night nameplate capacity=40.35/(0.8*0.95)=53.0921 kWh. Option C retains the two-LV_32 (64 kWh) stack for the comparison. The existing battery efficiency convention remains preliminary; this update changes the consumption split only.</a:t>
+            </a:r>
+          </a:p>
+          <a:p xmlns:a="http://schemas.openxmlformats.org/drawingml/2006/main">
+            <a:r>
+              <a:t>Source: European Commission JRC PVGIS 5.3, retrieved 30 September 2026. https://re.jrc.ec.europa.eu/api/v5_3/PVcalc?lat=30.0444&amp;lon=31.2357&amp;peakpower=1&amp;loss=14&amp;angle=30&amp;aspect=0&amp;pvtechchoice=crystSi&amp;mountingplace=free&amp;outputformat=json</a:t>
+            </a:r>
+          </a:p>
+          <a:p xmlns:a="http://schemas.openxmlformats.org/drawingml/2006/main">
+            <a:r>
+              <a:t>PVGIS-SARAH3 / ERA5, 2005-2023. Cairo reference location 30.0444 N, 31.2357 E; 1 kWp crystalline silicon; fixed south-facing, 30-degree tilt, free-standing; user-entered system loss 14%. This is modeled PV electricity output, not irradiance or a site measurement. Local rooftop shading is not surveyed. Existing battery efficiency convention remains preliminary and needs harmonization before a customer quote.</a:t>
+            </a:r>
+          </a:p>
+          <a:p xmlns:a="http://schemas.openxmlformats.org/drawingml/2006/main">
+            <a:r>
+              <a:t>Recalculated scenarios: [{"C":0,"U":0,"P":8.5,"inv":10,"G":42.330000000000005,"direct":40.35,"battery":0,"M":1210.5,"newbill":3453.61,"saving":3413.61,"price":140800,"payback":3.4372213970937904},{"C":16,"U":12.8,"P":11,"inv":12,"G":54.78,"direct":40.35,"battery":12.8,"M":826.5,"newbill":2254.405,"saving":4612.8150000000005,"price":394240,"payback":7.12218750011291},{"C":64,"U":51.2,"P":17,"inv":20,"G":84.66000000000001,"direct":40.35,"battery":40.35,"M":0,"newbill":9,"saving":6858.22,"price":1154560,"payback":14.028907403573132}]</a:t>
             </a:r>
           </a:p>
         </p:txBody>
@@ -845,7 +889,26 @@
         <p:txBody>
           <a:bodyPr xmlns:a="http://schemas.openxmlformats.org/drawingml/2006/main"/>
           <a:lstStyle xmlns:a="http://schemas.openxmlformats.org/drawingml/2006/main"/>
-          <a:p xmlns:a="http://schemas.openxmlformats.org/drawingml/2006/main"/>
+          <a:p xmlns:a="http://schemas.openxmlformats.org/drawingml/2006/main">
+            <a:r>
+              <a:t>Day/night split set to 50%/50% by user request on 30 September 2026. Scenario assumption, not measured. E=80.7, D=N=40.35 kWh/day. Required whole-night nameplate capacity=40.35/(0.8*0.95)=53.0921 kWh. Option C retains the two-LV_32 (64 kWh) stack for the comparison. The existing battery efficiency convention remains preliminary; this update changes the consumption split only.</a:t>
+            </a:r>
+          </a:p>
+          <a:p xmlns:a="http://schemas.openxmlformats.org/drawingml/2006/main">
+            <a:r>
+              <a:t>Source: European Commission JRC PVGIS 5.3, retrieved 30 September 2026. https://re.jrc.ec.europa.eu/api/v5_3/PVcalc?lat=30.0444&amp;lon=31.2357&amp;peakpower=1&amp;loss=14&amp;angle=30&amp;aspect=0&amp;pvtechchoice=crystSi&amp;mountingplace=free&amp;outputformat=json</a:t>
+            </a:r>
+          </a:p>
+          <a:p xmlns:a="http://schemas.openxmlformats.org/drawingml/2006/main">
+            <a:r>
+              <a:t>PVGIS-SARAH3 / ERA5, 2005-2023. Cairo reference location 30.0444 N, 31.2357 E; 1 kWp crystalline silicon; fixed south-facing, 30-degree tilt, free-standing; user-entered system loss 14%. This is modeled PV electricity output, not irradiance or a site measurement. Local rooftop shading is not surveyed. Existing battery efficiency convention remains preliminary and needs harmonization before a customer quote.</a:t>
+            </a:r>
+          </a:p>
+          <a:p xmlns:a="http://schemas.openxmlformats.org/drawingml/2006/main">
+            <a:r>
+              <a:t>Recalculated scenarios: [{"C":0,"U":0,"P":8.5,"inv":10,"G":42.330000000000005,"direct":40.35,"battery":0,"M":1210.5,"newbill":3453.61,"saving":3413.61,"price":140800,"payback":3.4372213970937904},{"C":16,"U":12.8,"P":11,"inv":12,"G":54.78,"direct":40.35,"battery":12.8,"M":826.5,"newbill":2254.405,"saving":4612.8150000000005,"price":394240,"payback":7.12218750011291},{"C":64,"U":51.2,"P":17,"inv":20,"G":84.66000000000001,"direct":40.35,"battery":40.35,"M":0,"newbill":9,"saving":6858.22,"price":1154560,"payback":14.028907403573132}]</a:t>
+            </a:r>
+          </a:p>
         </p:txBody>
       </p:sp>
       <p:sp>
@@ -913,6 +976,11 @@
           <a:lstStyle xmlns:a="http://schemas.openxmlformats.org/drawingml/2006/main"/>
           <a:p xmlns:a="http://schemas.openxmlformats.org/drawingml/2006/main">
             <a:r>
+              <a:t>Day/night split set to 50%/50% by user request on 30 September 2026. Scenario assumption, not measured. E=80.7, D=N=40.35 kWh/day. Required whole-night nameplate capacity=40.35/(0.8*0.95)=53.0921 kWh. Option C retains the two-LV_32 (64 kWh) stack for the comparison. The existing battery efficiency convention remains preliminary; this update changes the consumption split only.</a:t>
+            </a:r>
+          </a:p>
+          <a:p xmlns:a="http://schemas.openxmlformats.org/drawingml/2006/main">
+            <a:r>
               <a:t>Source: European Commission JRC PVGIS 5.3, retrieved 30 September 2026. https://re.jrc.ec.europa.eu/api/v5_3/PVcalc?lat=30.0444&amp;lon=31.2357&amp;peakpower=1&amp;loss=14&amp;angle=30&amp;aspect=0&amp;pvtechchoice=crystSi&amp;mountingplace=free&amp;outputformat=json</a:t>
             </a:r>
           </a:p>
@@ -923,7 +991,7 @@
           </a:p>
           <a:p xmlns:a="http://schemas.openxmlformats.org/drawingml/2006/main">
             <a:r>
-              <a:t>Recalculated using Y=4.98 and the existing 58% night-share scenario. Monthly saving remains an average-day illustration, not a twelve-month hourly simulation. Battery discharge losses require a separate model correction.</a:t>
+              <a:t>Recalculated scenarios: [{"C":0,"U":0,"P":8.5,"inv":10,"G":42.330000000000005,"direct":40.35,"battery":0,"M":1210.5,"newbill":3453.61,"saving":3413.61,"price":140800,"payback":3.4372213970937904},{"C":16,"U":12.8,"P":11,"inv":12,"G":54.78,"direct":40.35,"battery":12.8,"M":826.5,"newbill":2254.405,"saving":4612.8150000000005,"price":394240,"payback":7.12218750011291},{"C":64,"U":51.2,"P":17,"inv":20,"G":84.66000000000001,"direct":40.35,"battery":40.35,"M":0,"newbill":9,"saving":6858.22,"price":1154560,"payback":14.028907403573132}]</a:t>
             </a:r>
           </a:p>
         </p:txBody>
@@ -993,6 +1061,11 @@
           <a:lstStyle xmlns:a="http://schemas.openxmlformats.org/drawingml/2006/main"/>
           <a:p xmlns:a="http://schemas.openxmlformats.org/drawingml/2006/main">
             <a:r>
+              <a:t>Day/night split set to 50%/50% by user request on 30 September 2026. Scenario assumption, not measured. E=80.7, D=N=40.35 kWh/day. Required whole-night nameplate capacity=40.35/(0.8*0.95)=53.0921 kWh. Option C retains the two-LV_32 (64 kWh) stack for the comparison. The existing battery efficiency convention remains preliminary; this update changes the consumption split only.</a:t>
+            </a:r>
+          </a:p>
+          <a:p xmlns:a="http://schemas.openxmlformats.org/drawingml/2006/main">
+            <a:r>
               <a:t>Source: European Commission JRC PVGIS 5.3, retrieved 30 September 2026. https://re.jrc.ec.europa.eu/api/v5_3/PVcalc?lat=30.0444&amp;lon=31.2357&amp;peakpower=1&amp;loss=14&amp;angle=30&amp;aspect=0&amp;pvtechchoice=crystSi&amp;mountingplace=free&amp;outputformat=json</a:t>
             </a:r>
           </a:p>
@@ -1003,7 +1076,7 @@
           </a:p>
           <a:p xmlns:a="http://schemas.openxmlformats.org/drawingml/2006/main">
             <a:r>
-              <a:t>A: (7 × 8000 + 8 × 6000) × 1.10 = 114400. B: unchanged 372240. C: (17 × 8000 + 20 × 6000) × 1.10 + 64 × 13640 = 1154560.</a:t>
+              <a:t>Recalculated scenarios: [{"C":0,"U":0,"P":8.5,"inv":10,"G":42.330000000000005,"direct":40.35,"battery":0,"M":1210.5,"newbill":3453.61,"saving":3413.61,"price":140800,"payback":3.4372213970937904},{"C":16,"U":12.8,"P":11,"inv":12,"G":54.78,"direct":40.35,"battery":12.8,"M":826.5,"newbill":2254.405,"saving":4612.8150000000005,"price":394240,"payback":7.12218750011291},{"C":64,"U":51.2,"P":17,"inv":20,"G":84.66000000000001,"direct":40.35,"battery":40.35,"M":0,"newbill":9,"saving":6858.22,"price":1154560,"payback":14.028907403573132}]</a:t>
             </a:r>
           </a:p>
         </p:txBody>
@@ -1073,6 +1146,11 @@
           <a:lstStyle xmlns:a="http://schemas.openxmlformats.org/drawingml/2006/main"/>
           <a:p xmlns:a="http://schemas.openxmlformats.org/drawingml/2006/main">
             <a:r>
+              <a:t>Day/night split set to 50%/50% by user request on 30 September 2026. Scenario assumption, not measured. E=80.7, D=N=40.35 kWh/day. Required whole-night nameplate capacity=40.35/(0.8*0.95)=53.0921 kWh. Option C retains the two-LV_32 (64 kWh) stack for the comparison. The existing battery efficiency convention remains preliminary; this update changes the consumption split only.</a:t>
+            </a:r>
+          </a:p>
+          <a:p xmlns:a="http://schemas.openxmlformats.org/drawingml/2006/main">
+            <a:r>
               <a:t>Source: European Commission JRC PVGIS 5.3, retrieved 30 September 2026. https://re.jrc.ec.europa.eu/api/v5_3/PVcalc?lat=30.0444&amp;lon=31.2357&amp;peakpower=1&amp;loss=14&amp;angle=30&amp;aspect=0&amp;pvtechchoice=crystSi&amp;mountingplace=free&amp;outputformat=json</a:t>
             </a:r>
           </a:p>
@@ -1083,7 +1161,7 @@
           </a:p>
           <a:p xmlns:a="http://schemas.openxmlformats.org/drawingml/2006/main">
             <a:r>
-              <a:t>Recalculated using Y=4.98 and the existing 58% night-share scenario. Monthly saving remains an average-day illustration, not a twelve-month hourly simulation. Battery discharge losses require a separate model correction.</a:t>
+              <a:t>Recalculated scenarios: [{"C":0,"U":0,"P":8.5,"inv":10,"G":42.330000000000005,"direct":40.35,"battery":0,"M":1210.5,"newbill":3453.61,"saving":3413.61,"price":140800,"payback":3.4372213970937904},{"C":16,"U":12.8,"P":11,"inv":12,"G":54.78,"direct":40.35,"battery":12.8,"M":826.5,"newbill":2254.405,"saving":4612.8150000000005,"price":394240,"payback":7.12218750011291},{"C":64,"U":51.2,"P":17,"inv":20,"G":84.66000000000001,"direct":40.35,"battery":40.35,"M":0,"newbill":9,"saving":6858.22,"price":1154560,"payback":14.028907403573132}]</a:t>
             </a:r>
           </a:p>
         </p:txBody>
@@ -1153,6 +1231,11 @@
           <a:lstStyle xmlns:a="http://schemas.openxmlformats.org/drawingml/2006/main"/>
           <a:p xmlns:a="http://schemas.openxmlformats.org/drawingml/2006/main">
             <a:r>
+              <a:t>Day/night split set to 50%/50% by user request on 30 September 2026. Scenario assumption, not measured. E=80.7, D=N=40.35 kWh/day. Required whole-night nameplate capacity=40.35/(0.8*0.95)=53.0921 kWh. Option C retains the two-LV_32 (64 kWh) stack for the comparison. The existing battery efficiency convention remains preliminary; this update changes the consumption split only.</a:t>
+            </a:r>
+          </a:p>
+          <a:p xmlns:a="http://schemas.openxmlformats.org/drawingml/2006/main">
+            <a:r>
               <a:t>Source: European Commission JRC PVGIS 5.3, retrieved 30 September 2026. https://re.jrc.ec.europa.eu/api/v5_3/PVcalc?lat=30.0444&amp;lon=31.2357&amp;peakpower=1&amp;loss=14&amp;angle=30&amp;aspect=0&amp;pvtechchoice=crystSi&amp;mountingplace=free&amp;outputformat=json</a:t>
             </a:r>
           </a:p>
@@ -1163,7 +1246,7 @@
           </a:p>
           <a:p xmlns:a="http://schemas.openxmlformats.org/drawingml/2006/main">
             <a:r>
-              <a:t>Recalculated using Y=4.98 and the existing 58% night-share scenario. Monthly saving remains an average-day illustration, not a twelve-month hourly simulation. Battery discharge losses require a separate model correction.</a:t>
+              <a:t>Recalculated scenarios: [{"C":0,"U":0,"P":8.5,"inv":10,"G":42.330000000000005,"direct":40.35,"battery":0,"M":1210.5,"newbill":3453.61,"saving":3413.61,"price":140800,"payback":3.4372213970937904},{"C":16,"U":12.8,"P":11,"inv":12,"G":54.78,"direct":40.35,"battery":12.8,"M":826.5,"newbill":2254.405,"saving":4612.8150000000005,"price":394240,"payback":7.12218750011291},{"C":64,"U":51.2,"P":17,"inv":20,"G":84.66000000000001,"direct":40.35,"battery":40.35,"M":0,"newbill":9,"saving":6858.22,"price":1154560,"payback":14.028907403573132}]</a:t>
             </a:r>
           </a:p>
         </p:txBody>
@@ -1233,6 +1316,11 @@
           <a:lstStyle xmlns:a="http://schemas.openxmlformats.org/drawingml/2006/main"/>
           <a:p xmlns:a="http://schemas.openxmlformats.org/drawingml/2006/main">
             <a:r>
+              <a:t>Day/night split set to 50%/50% by user request on 30 September 2026. Scenario assumption, not measured. E=80.7, D=N=40.35 kWh/day. Required whole-night nameplate capacity=40.35/(0.8*0.95)=53.0921 kWh. Option C retains the two-LV_32 (64 kWh) stack for the comparison. The existing battery efficiency convention remains preliminary; this update changes the consumption split only.</a:t>
+            </a:r>
+          </a:p>
+          <a:p xmlns:a="http://schemas.openxmlformats.org/drawingml/2006/main">
+            <a:r>
               <a:t>Source: European Commission JRC PVGIS 5.3, retrieved 30 September 2026. https://re.jrc.ec.europa.eu/api/v5_3/PVcalc?lat=30.0444&amp;lon=31.2357&amp;peakpower=1&amp;loss=14&amp;angle=30&amp;aspect=0&amp;pvtechchoice=crystSi&amp;mountingplace=free&amp;outputformat=json</a:t>
             </a:r>
           </a:p>
@@ -1243,7 +1331,7 @@
           </a:p>
           <a:p xmlns:a="http://schemas.openxmlformats.org/drawingml/2006/main">
             <a:r>
-              <a:t>Recalculated using Y=4.98 and the existing 58% night-share scenario. Monthly saving remains an average-day illustration, not a twelve-month hourly simulation. Battery discharge losses require a separate model correction.</a:t>
+              <a:t>Recalculated scenarios: [{"C":0,"U":0,"P":8.5,"inv":10,"G":42.330000000000005,"direct":40.35,"battery":0,"M":1210.5,"newbill":3453.61,"saving":3413.61,"price":140800,"payback":3.4372213970937904},{"C":16,"U":12.8,"P":11,"inv":12,"G":54.78,"direct":40.35,"battery":12.8,"M":826.5,"newbill":2254.405,"saving":4612.8150000000005,"price":394240,"payback":7.12218750011291},{"C":64,"U":51.2,"P":17,"inv":20,"G":84.66000000000001,"direct":40.35,"battery":40.35,"M":0,"newbill":9,"saving":6858.22,"price":1154560,"payback":14.028907403573132}]</a:t>
             </a:r>
           </a:p>
         </p:txBody>
@@ -1313,6 +1401,11 @@
           <a:lstStyle xmlns:a="http://schemas.openxmlformats.org/drawingml/2006/main"/>
           <a:p xmlns:a="http://schemas.openxmlformats.org/drawingml/2006/main">
             <a:r>
+              <a:t>Day/night split set to 50%/50% by user request on 30 September 2026. Scenario assumption, not measured. E=80.7, D=N=40.35 kWh/day. Required whole-night nameplate capacity=40.35/(0.8*0.95)=53.0921 kWh. Option C retains the two-LV_32 (64 kWh) stack for the comparison. The existing battery efficiency convention remains preliminary; this update changes the consumption split only.</a:t>
+            </a:r>
+          </a:p>
+          <a:p xmlns:a="http://schemas.openxmlformats.org/drawingml/2006/main">
+            <a:r>
               <a:t>Source: European Commission JRC PVGIS 5.3, retrieved 30 September 2026. https://re.jrc.ec.europa.eu/api/v5_3/PVcalc?lat=30.0444&amp;lon=31.2357&amp;peakpower=1&amp;loss=14&amp;angle=30&amp;aspect=0&amp;pvtechchoice=crystSi&amp;mountingplace=free&amp;outputformat=json</a:t>
             </a:r>
           </a:p>
@@ -1323,7 +1416,7 @@
           </a:p>
           <a:p xmlns:a="http://schemas.openxmlformats.org/drawingml/2006/main">
             <a:r>
-              <a:t>Recalculated using Y=4.98 and the existing 58% night-share scenario. Monthly saving remains an average-day illustration, not a twelve-month hourly simulation. Battery discharge losses require a separate model correction.</a:t>
+              <a:t>Recalculated scenarios: [{"C":0,"U":0,"P":8.5,"inv":10,"G":42.330000000000005,"direct":40.35,"battery":0,"M":1210.5,"newbill":3453.61,"saving":3413.61,"price":140800,"payback":3.4372213970937904},{"C":16,"U":12.8,"P":11,"inv":12,"G":54.78,"direct":40.35,"battery":12.8,"M":826.5,"newbill":2254.405,"saving":4612.8150000000005,"price":394240,"payback":7.12218750011291},{"C":64,"U":51.2,"P":17,"inv":20,"G":84.66000000000001,"direct":40.35,"battery":40.35,"M":0,"newbill":9,"saving":6858.22,"price":1154560,"payback":14.028907403573132}]</a:t>
             </a:r>
           </a:p>
         </p:txBody>
@@ -4350,17 +4443,17 @@
   </p:cSld>
   <p:clrMap bg1="lt1" tx1="dk1" bg2="lt2" tx2="dk2" accent1="accent1" accent2="accent2" accent3="accent3" accent4="accent4" accent5="accent5" accent6="accent6" hlink="hlink" folHlink="folHlink"/>
   <p:sldLayoutIdLst>
-    <p:sldLayoutId xmlns:r="http://schemas.openxmlformats.org/officeDocument/2006/relationships" id="2147483649" r:id="R2f6ffdde4b604957"/>
-    <p:sldLayoutId xmlns:r="http://schemas.openxmlformats.org/officeDocument/2006/relationships" id="2147483650" r:id="R60c2fd42e5644cbe"/>
-    <p:sldLayoutId xmlns:r="http://schemas.openxmlformats.org/officeDocument/2006/relationships" id="2147483651" r:id="R04ae5f092ec146e8"/>
-    <p:sldLayoutId xmlns:r="http://schemas.openxmlformats.org/officeDocument/2006/relationships" id="2147483652" r:id="Rcc9d6c2f625945b6"/>
-    <p:sldLayoutId xmlns:r="http://schemas.openxmlformats.org/officeDocument/2006/relationships" id="2147483653" r:id="Re89d97fadf2548b6"/>
-    <p:sldLayoutId xmlns:r="http://schemas.openxmlformats.org/officeDocument/2006/relationships" id="2147483654" r:id="R31f2d4700a2246ea"/>
-    <p:sldLayoutId xmlns:r="http://schemas.openxmlformats.org/officeDocument/2006/relationships" id="2147483655" r:id="Rf77f5282d2a74f58"/>
-    <p:sldLayoutId xmlns:r="http://schemas.openxmlformats.org/officeDocument/2006/relationships" id="2147483656" r:id="R0b980e7cbcae4399"/>
-    <p:sldLayoutId xmlns:r="http://schemas.openxmlformats.org/officeDocument/2006/relationships" id="2147483657" r:id="R5d6b83578e194eb7"/>
-    <p:sldLayoutId xmlns:r="http://schemas.openxmlformats.org/officeDocument/2006/relationships" id="2147483658" r:id="R6b9ec6ab3621493a"/>
-    <p:sldLayoutId xmlns:r="http://schemas.openxmlformats.org/officeDocument/2006/relationships" id="2147483659" r:id="Rc95b93c8feb349ca"/>
+    <p:sldLayoutId xmlns:r="http://schemas.openxmlformats.org/officeDocument/2006/relationships" id="2147483649" r:id="R7c9911751cfb4599"/>
+    <p:sldLayoutId xmlns:r="http://schemas.openxmlformats.org/officeDocument/2006/relationships" id="2147483650" r:id="R88b0b6c2aebc4d80"/>
+    <p:sldLayoutId xmlns:r="http://schemas.openxmlformats.org/officeDocument/2006/relationships" id="2147483651" r:id="R0bafb86b5d624099"/>
+    <p:sldLayoutId xmlns:r="http://schemas.openxmlformats.org/officeDocument/2006/relationships" id="2147483652" r:id="Rc052efd513a94629"/>
+    <p:sldLayoutId xmlns:r="http://schemas.openxmlformats.org/officeDocument/2006/relationships" id="2147483653" r:id="R6f6c6fc69f964950"/>
+    <p:sldLayoutId xmlns:r="http://schemas.openxmlformats.org/officeDocument/2006/relationships" id="2147483654" r:id="R66c0c43a215e420a"/>
+    <p:sldLayoutId xmlns:r="http://schemas.openxmlformats.org/officeDocument/2006/relationships" id="2147483655" r:id="R47c6beec6c704d62"/>
+    <p:sldLayoutId xmlns:r="http://schemas.openxmlformats.org/officeDocument/2006/relationships" id="2147483656" r:id="R2aa53ecea75b49f3"/>
+    <p:sldLayoutId xmlns:r="http://schemas.openxmlformats.org/officeDocument/2006/relationships" id="2147483657" r:id="R1bb1c0fc06b343b3"/>
+    <p:sldLayoutId xmlns:r="http://schemas.openxmlformats.org/officeDocument/2006/relationships" id="2147483658" r:id="Re1e7364add86416f"/>
+    <p:sldLayoutId xmlns:r="http://schemas.openxmlformats.org/officeDocument/2006/relationships" id="2147483659" r:id="R9fe582dc16ec40b4"/>
   </p:sldLayoutIdLst>
   <p:txStyles>
     <p:titleStyle>
@@ -5495,7 +5588,7 @@
                           <a:ea typeface="Arial"/>
                           <a:cs typeface="Arial"/>
                         </a:rPr>
-                        <a:t>Night share</a:t>
+                        <a:t>Day / night share</a:t>
                       </a:r>
                     </a:p>
                   </a:txBody>
@@ -5519,7 +5612,7 @@
                           <a:ea typeface="Arial"/>
                           <a:cs typeface="Arial"/>
                         </a:rPr>
-                        <a:t>58%</a:t>
+                        <a:t>50% / 50%</a:t>
                       </a:r>
                     </a:p>
                   </a:txBody>
@@ -5543,7 +5636,7 @@
                           <a:ea typeface="Arial"/>
                           <a:cs typeface="Arial"/>
                         </a:rPr>
-                        <a:t>Estimated from equipment; confirm opening hours</a:t>
+                        <a:t>Scenario assumption; not measured at the shop</a:t>
                       </a:r>
                     </a:p>
                   </a:txBody>
@@ -6041,6 +6134,7 @@
           <a:lstStyle xmlns:a="http://schemas.openxmlformats.org/drawingml/2006/main"/>
           <a:p xmlns:a="http://schemas.openxmlformats.org/drawingml/2006/main">
             <a:pPr>
+              <a:buNone/>
               <a:defRPr sz="1350" b="1">
                 <a:solidFill>
                   <a:srgbClr val="B84E0E"/>
@@ -6098,6 +6192,7 @@
           <a:lstStyle xmlns:a="http://schemas.openxmlformats.org/drawingml/2006/main"/>
           <a:p xmlns:a="http://schemas.openxmlformats.org/drawingml/2006/main">
             <a:pPr>
+              <a:buNone/>
               <a:defRPr sz="3150" b="1">
                 <a:solidFill>
                   <a:srgbClr val="14171C"/>
@@ -6155,6 +6250,7 @@
           <a:lstStyle xmlns:a="http://schemas.openxmlformats.org/drawingml/2006/main"/>
           <a:p xmlns:a="http://schemas.openxmlformats.org/drawingml/2006/main">
             <a:pPr>
+              <a:buNone/>
               <a:defRPr sz="1500" b="0">
                 <a:solidFill>
                   <a:srgbClr val="4A5260"/>
@@ -6180,7 +6276,7 @@
       </p:sp>
       <p:graphicFrame>
         <p:nvGraphicFramePr>
-          <p:cNvPr id="10" name=""/>
+          <p:cNvPr id="12" name=""/>
           <p:cNvGraphicFramePr/>
           <p:nvPr/>
         </p:nvGraphicFramePr>
@@ -7549,6 +7645,7 @@
           <a:lstStyle xmlns:a="http://schemas.openxmlformats.org/drawingml/2006/main"/>
           <a:p xmlns:a="http://schemas.openxmlformats.org/drawingml/2006/main">
             <a:pPr>
+              <a:buNone/>
               <a:defRPr sz="1200" b="0">
                 <a:solidFill>
                   <a:srgbClr val="4A5260"/>
@@ -7606,6 +7703,7 @@
           <a:lstStyle xmlns:a="http://schemas.openxmlformats.org/drawingml/2006/main"/>
           <a:p xmlns:a="http://schemas.openxmlformats.org/drawingml/2006/main">
             <a:pPr>
+              <a:buNone/>
               <a:defRPr sz="1200" b="0">
                 <a:solidFill>
                   <a:srgbClr val="4A5260"/>
@@ -7692,6 +7790,7 @@
           <a:lstStyle xmlns:a="http://schemas.openxmlformats.org/drawingml/2006/main"/>
           <a:p xmlns:a="http://schemas.openxmlformats.org/drawingml/2006/main">
             <a:pPr>
+              <a:buNone/>
               <a:defRPr sz="1350" b="1">
                 <a:solidFill>
                   <a:srgbClr val="B84E0E"/>
@@ -7749,6 +7848,7 @@
           <a:lstStyle xmlns:a="http://schemas.openxmlformats.org/drawingml/2006/main"/>
           <a:p xmlns:a="http://schemas.openxmlformats.org/drawingml/2006/main">
             <a:pPr>
+              <a:buNone/>
               <a:defRPr sz="3150" b="1">
                 <a:solidFill>
                   <a:srgbClr val="14171C"/>
@@ -7806,6 +7906,7 @@
           <a:lstStyle xmlns:a="http://schemas.openxmlformats.org/drawingml/2006/main"/>
           <a:p xmlns:a="http://schemas.openxmlformats.org/drawingml/2006/main">
             <a:pPr>
+              <a:buNone/>
               <a:defRPr sz="2100" b="1">
                 <a:solidFill>
                   <a:srgbClr val="14171C"/>
@@ -7863,6 +7964,7 @@
           <a:lstStyle xmlns:a="http://schemas.openxmlformats.org/drawingml/2006/main"/>
           <a:p xmlns:a="http://schemas.openxmlformats.org/drawingml/2006/main">
             <a:pPr>
+              <a:buNone/>
               <a:defRPr sz="1650" b="0">
                 <a:solidFill>
                   <a:srgbClr val="B84E0E"/>
@@ -7886,6 +7988,7 @@
           </a:p>
           <a:p xmlns:a="http://schemas.openxmlformats.org/drawingml/2006/main">
             <a:pPr>
+              <a:buNone/>
               <a:defRPr sz="1650" b="0">
                 <a:solidFill>
                   <a:srgbClr val="B84E0E"/>
@@ -7943,6 +8046,7 @@
           <a:lstStyle xmlns:a="http://schemas.openxmlformats.org/drawingml/2006/main"/>
           <a:p xmlns:a="http://schemas.openxmlformats.org/drawingml/2006/main">
             <a:pPr>
+              <a:buNone/>
               <a:defRPr sz="1650" b="0">
                 <a:solidFill>
                   <a:srgbClr val="14171C"/>
@@ -7966,6 +8070,7 @@
           </a:p>
           <a:p xmlns:a="http://schemas.openxmlformats.org/drawingml/2006/main">
             <a:pPr>
+              <a:buNone/>
               <a:defRPr sz="1650" b="0">
                 <a:solidFill>
                   <a:srgbClr val="14171C"/>
@@ -8023,6 +8128,7 @@
           <a:lstStyle xmlns:a="http://schemas.openxmlformats.org/drawingml/2006/main"/>
           <a:p xmlns:a="http://schemas.openxmlformats.org/drawingml/2006/main">
             <a:pPr>
+              <a:buNone/>
               <a:defRPr sz="1800" b="1">
                 <a:solidFill>
                   <a:srgbClr val="B84E0E"/>
@@ -8080,6 +8186,7 @@
           <a:lstStyle xmlns:a="http://schemas.openxmlformats.org/drawingml/2006/main"/>
           <a:p xmlns:a="http://schemas.openxmlformats.org/drawingml/2006/main">
             <a:pPr>
+              <a:buNone/>
               <a:defRPr sz="1500" b="0">
                 <a:solidFill>
                   <a:srgbClr val="4A5260"/>
@@ -8103,6 +8210,7 @@
           </a:p>
           <a:p xmlns:a="http://schemas.openxmlformats.org/drawingml/2006/main">
             <a:pPr>
+              <a:buNone/>
               <a:defRPr sz="1500" b="0">
                 <a:solidFill>
                   <a:srgbClr val="4A5260"/>
@@ -8126,6 +8234,7 @@
           </a:p>
           <a:p xmlns:a="http://schemas.openxmlformats.org/drawingml/2006/main">
             <a:pPr>
+              <a:buNone/>
               <a:defRPr sz="1500" b="0">
                 <a:solidFill>
                   <a:srgbClr val="4A5260"/>
@@ -8183,6 +8292,7 @@
           <a:lstStyle xmlns:a="http://schemas.openxmlformats.org/drawingml/2006/main"/>
           <a:p xmlns:a="http://schemas.openxmlformats.org/drawingml/2006/main">
             <a:pPr>
+              <a:buNone/>
               <a:defRPr sz="1200" b="0">
                 <a:solidFill>
                   <a:srgbClr val="4A5260"/>
@@ -8911,7 +9021,7 @@
                 <a:ea typeface="Consolas"/>
                 <a:cs typeface="Consolas"/>
               </a:rPr>
-              <a:t>58%</a:t>
+              <a:t>50%</a:t>
             </a:r>
           </a:p>
         </p:txBody>
@@ -8933,7 +9043,7 @@
         <p:spPr>
           <a:xfrm xmlns:a="http://schemas.openxmlformats.org/drawingml/2006/main">
             <a:off x="9055100" y="2679700"/>
-            <a:ext cx="2120900" cy="381000"/>
+            <a:ext cx="2120900" cy="515112"/>
           </a:xfrm>
           <a:prstGeom xmlns:a="http://schemas.openxmlformats.org/drawingml/2006/main" prst="rect">
             <a:avLst/>
@@ -8961,8 +9071,8 @@
                 <a:ea typeface="Arial"/>
                 <a:cs typeface="Arial"/>
               </a:rPr>
-              <a:t>of daily energy used
-after sunset (N)</a:t>
+              <a:t>assumed night share
+50% day / 50% night</a:t>
             </a:r>
           </a:p>
         </p:txBody>
@@ -10928,7 +11038,7 @@
                 <a:ea typeface="Consolas"/>
                 <a:cs typeface="Consolas"/>
               </a:rPr>
-              <a:t>N = E × 58%</a:t>
+              <a:t>N = E × 50%</a:t>
             </a:r>
           </a:p>
         </p:txBody>
@@ -10978,7 +11088,7 @@
                 <a:ea typeface="Arial"/>
                 <a:cs typeface="Arial"/>
               </a:rPr>
-              <a:t>46.8 kWh at night</a:t>
+              <a:t>40.35 kWh at night</a:t>
             </a:r>
           </a:p>
         </p:txBody>
@@ -11078,7 +11188,7 @@
                 <a:ea typeface="Arial"/>
                 <a:cs typeface="Arial"/>
               </a:rPr>
-              <a:t>33.9 kWh in daytime</a:t>
+              <a:t>40.35 kWh in daytime</a:t>
             </a:r>
           </a:p>
         </p:txBody>
@@ -11614,7 +11724,7 @@
         <p:spPr>
           <a:xfrm xmlns:a="http://schemas.openxmlformats.org/drawingml/2006/main">
             <a:off x="8195733" y="2832100"/>
-            <a:ext cx="2980266" cy="254000"/>
+            <a:ext cx="2980266" cy="475488"/>
           </a:xfrm>
           <a:prstGeom xmlns:a="http://schemas.openxmlformats.org/drawingml/2006/main" prst="rect">
             <a:avLst/>
@@ -11642,7 +11752,7 @@
                 <a:ea typeface="Arial"/>
                 <a:cs typeface="Arial"/>
               </a:rPr>
-              <a:t>46.8 ÷ 0.76 = 61.6 kWh for the whole night</a:t>
+              <a:t>40.35 ÷ 0.76 = 53.1 kWh for the whole night</a:t>
             </a:r>
           </a:p>
         </p:txBody>
@@ -12180,7 +12290,7 @@
                           <a:ea typeface="Arial"/>
                           <a:cs typeface="Arial"/>
                         </a:rPr>
-                        <a:t>7.0 kWp</a:t>
+                        <a:t>8.5 kWp</a:t>
                       </a:r>
                     </a:p>
                   </a:txBody>
@@ -12204,7 +12314,7 @@
                           <a:ea typeface="Arial"/>
                           <a:cs typeface="Arial"/>
                         </a:rPr>
-                        <a:t>10 kWp</a:t>
+                        <a:t>11.0 kWp</a:t>
                       </a:r>
                     </a:p>
                   </a:txBody>
@@ -12376,7 +12486,7 @@
                           <a:ea typeface="Arial"/>
                           <a:cs typeface="Arial"/>
                         </a:rPr>
-                        <a:t>8 kW</a:t>
+                        <a:t>10 kW</a:t>
                       </a:r>
                     </a:p>
                   </a:txBody>
@@ -12400,7 +12510,7 @@
                           <a:ea typeface="Arial"/>
                           <a:cs typeface="Arial"/>
                         </a:rPr>
-                        <a:t>10 kW</a:t>
+                        <a:t>12 kW</a:t>
                       </a:r>
                     </a:p>
                   </a:txBody>
@@ -12474,7 +12584,7 @@
                           <a:ea typeface="Arial"/>
                           <a:cs typeface="Arial"/>
                         </a:rPr>
-                        <a:t>≈ 42 m²</a:t>
+                        <a:t>≈ 51 m²</a:t>
                       </a:r>
                     </a:p>
                   </a:txBody>
@@ -12498,7 +12608,7 @@
                           <a:ea typeface="Arial"/>
                           <a:cs typeface="Arial"/>
                         </a:rPr>
-                        <a:t>≈ 60 m²</a:t>
+                        <a:t>≈ 66 m²</a:t>
                       </a:r>
                     </a:p>
                   </a:txBody>
@@ -12572,7 +12682,7 @@
                           <a:ea typeface="Arial"/>
                           <a:cs typeface="Arial"/>
                         </a:rPr>
-                        <a:t>114,400</a:t>
+                        <a:t>140,800</a:t>
                       </a:r>
                     </a:p>
                   </a:txBody>
@@ -12596,7 +12706,7 @@
                           <a:ea typeface="Arial"/>
                           <a:cs typeface="Arial"/>
                         </a:rPr>
-                        <a:t>372,240</a:t>
+                        <a:t>394,240</a:t>
                       </a:r>
                     </a:p>
                   </a:txBody>
@@ -12973,7 +13083,7 @@
                           <a:ea typeface="Arial"/>
                           <a:cs typeface="Arial"/>
                         </a:rPr>
-                        <a:t>34.9</a:t>
+                        <a:t>42.3</a:t>
                       </a:r>
                     </a:p>
                   </a:txBody>
@@ -12997,7 +13107,7 @@
                           <a:ea typeface="Arial"/>
                           <a:cs typeface="Arial"/>
                         </a:rPr>
-                        <a:t>49.8</a:t>
+                        <a:t>54.8</a:t>
                       </a:r>
                     </a:p>
                   </a:txBody>
@@ -13071,7 +13181,7 @@
                           <a:ea typeface="Arial"/>
                           <a:cs typeface="Arial"/>
                         </a:rPr>
-                        <a:t>33.9</a:t>
+                        <a:t>40.35</a:t>
                       </a:r>
                     </a:p>
                   </a:txBody>
@@ -13095,7 +13205,7 @@
                           <a:ea typeface="Arial"/>
                           <a:cs typeface="Arial"/>
                         </a:rPr>
-                        <a:t>33.9</a:t>
+                        <a:t>40.35</a:t>
                       </a:r>
                     </a:p>
                   </a:txBody>
@@ -13119,7 +13229,7 @@
                           <a:ea typeface="Arial"/>
                           <a:cs typeface="Arial"/>
                         </a:rPr>
-                        <a:t>33.9</a:t>
+                        <a:t>40.35</a:t>
                       </a:r>
                     </a:p>
                   </a:txBody>
@@ -13169,7 +13279,7 @@
                           <a:ea typeface="Arial"/>
                           <a:cs typeface="Arial"/>
                         </a:rPr>
-                        <a:t>0.0</a:t>
+                        <a:t>0.00</a:t>
                       </a:r>
                     </a:p>
                   </a:txBody>
@@ -13193,7 +13303,7 @@
                           <a:ea typeface="Arial"/>
                           <a:cs typeface="Arial"/>
                         </a:rPr>
-                        <a:t>12.8</a:t>
+                        <a:t>12.80</a:t>
                       </a:r>
                     </a:p>
                   </a:txBody>
@@ -13217,7 +13327,7 @@
                           <a:ea typeface="Arial"/>
                           <a:cs typeface="Arial"/>
                         </a:rPr>
-                        <a:t>46.8</a:t>
+                        <a:t>40.35</a:t>
                       </a:r>
                     </a:p>
                   </a:txBody>
@@ -13267,7 +13377,7 @@
                           <a:ea typeface="Arial"/>
                           <a:cs typeface="Arial"/>
                         </a:rPr>
-                        <a:t>1,404 kWh</a:t>
+                        <a:t>1,211 kWh</a:t>
                       </a:r>
                     </a:p>
                   </a:txBody>
@@ -13291,7 +13401,7 @@
                           <a:ea typeface="Arial"/>
                           <a:cs typeface="Arial"/>
                         </a:rPr>
-                        <a:t>1,020 kWh</a:t>
+                        <a:t>827 kWh</a:t>
                       </a:r>
                     </a:p>
                   </a:txBody>
@@ -13365,7 +13475,7 @@
                           <a:ea typeface="Arial"/>
                           <a:cs typeface="Arial"/>
                         </a:rPr>
-                        <a:t>4,000</a:t>
+                        <a:t>3,454</a:t>
                       </a:r>
                     </a:p>
                   </a:txBody>
@@ -13389,7 +13499,7 @@
                           <a:ea typeface="Arial"/>
                           <a:cs typeface="Arial"/>
                         </a:rPr>
-                        <a:t>2,917</a:t>
+                        <a:t>2,254</a:t>
                       </a:r>
                     </a:p>
                   </a:txBody>
@@ -13463,7 +13573,7 @@
                           <a:ea typeface="Arial"/>
                           <a:cs typeface="Arial"/>
                         </a:rPr>
-                        <a:t>2,867</a:t>
+                        <a:t>3,414</a:t>
                       </a:r>
                     </a:p>
                   </a:txBody>
@@ -13487,7 +13597,7 @@
                           <a:ea typeface="Arial"/>
                           <a:cs typeface="Arial"/>
                         </a:rPr>
-                        <a:t>3,950</a:t>
+                        <a:t>4,613</a:t>
                       </a:r>
                     </a:p>
                   </a:txBody>
@@ -13964,7 +14074,7 @@
                 <a:ea typeface="Consolas"/>
                 <a:cs typeface="Consolas"/>
               </a:rPr>
-              <a:t>3.3 yrs</a:t>
+              <a:t>3.4 yrs</a:t>
             </a:r>
           </a:p>
         </p:txBody>
@@ -14014,7 +14124,7 @@
                 <a:ea typeface="Consolas"/>
                 <a:cs typeface="Consolas"/>
               </a:rPr>
-              <a:t>114,400 ÷ 34,409</a:t>
+              <a:t>140,800 ÷ 40,963</a:t>
             </a:r>
           </a:p>
           <a:p xmlns:a="http://schemas.openxmlformats.org/drawingml/2006/main">
@@ -14033,7 +14143,7 @@
                 <a:ea typeface="Consolas"/>
                 <a:cs typeface="Consolas"/>
               </a:rPr>
-              <a:t>Saving 2,867 EGP a month</a:t>
+              <a:t>Saving 3,414 EGP a month</a:t>
             </a:r>
           </a:p>
         </p:txBody>
@@ -14190,7 +14300,7 @@
                 <a:ea typeface="Consolas"/>
                 <a:cs typeface="Consolas"/>
               </a:rPr>
-              <a:t>7.9 yrs</a:t>
+              <a:t>7.1 yrs</a:t>
             </a:r>
           </a:p>
         </p:txBody>
@@ -14240,7 +14350,7 @@
                 <a:ea typeface="Consolas"/>
                 <a:cs typeface="Consolas"/>
               </a:rPr>
-              <a:t>372,240 ÷ 47,404</a:t>
+              <a:t>394,240 ÷ 55,354</a:t>
             </a:r>
           </a:p>
           <a:p xmlns:a="http://schemas.openxmlformats.org/drawingml/2006/main">
@@ -14259,7 +14369,7 @@
                 <a:ea typeface="Consolas"/>
                 <a:cs typeface="Consolas"/>
               </a:rPr>
-              <a:t>Saving 3,950 EGP a month</a:t>
+              <a:t>Saving 4,613 EGP a month</a:t>
             </a:r>
           </a:p>
         </p:txBody>
@@ -14967,7 +15077,7 @@
                           <a:ea typeface="Arial"/>
                           <a:cs typeface="Arial"/>
                         </a:rPr>
-                        <a:t>3.3 yrs · 2,867</a:t>
+                        <a:t>3.4 yrs · 3,414</a:t>
                       </a:r>
                     </a:p>
                   </a:txBody>
@@ -14991,7 +15101,7 @@
                           <a:ea typeface="Arial"/>
                           <a:cs typeface="Arial"/>
                         </a:rPr>
-                        <a:t>1,907  (+961)</a:t>
+                        <a:t>2,347  (+1,067)</a:t>
                       </a:r>
                     </a:p>
                   </a:txBody>
@@ -15015,7 +15125,7 @@
                           <a:ea typeface="Arial"/>
                           <a:cs typeface="Arial"/>
                         </a:rPr>
-                        <a:t>1,192  (+1,676)</a:t>
+                        <a:t>1,467  (+1,947)</a:t>
                       </a:r>
                     </a:p>
                   </a:txBody>
@@ -15039,7 +15149,7 @@
                           <a:ea typeface="Arial"/>
                           <a:cs typeface="Arial"/>
                         </a:rPr>
-                        <a:t>953  (+1,914)</a:t>
+                        <a:t>1,173  (+2,240)</a:t>
                       </a:r>
                     </a:p>
                   </a:txBody>
@@ -15089,7 +15199,7 @@
                           <a:ea typeface="Arial"/>
                           <a:cs typeface="Arial"/>
                         </a:rPr>
-                        <a:t>7.9 yrs · 3,950</a:t>
+                        <a:t>7.1 yrs · 4,613</a:t>
                       </a:r>
                     </a:p>
                   </a:txBody>
@@ -15113,7 +15223,7 @@
                           <a:ea typeface="Arial"/>
                           <a:cs typeface="Arial"/>
                         </a:rPr>
-                        <a:t>6,204  (−2,254)</a:t>
+                        <a:t>6,571  (−1,958)</a:t>
                       </a:r>
                     </a:p>
                   </a:txBody>
@@ -15137,7 +15247,7 @@
                           <a:ea typeface="Arial"/>
                           <a:cs typeface="Arial"/>
                         </a:rPr>
-                        <a:t>3,878  (+73)</a:t>
+                        <a:t>4,107  (+506)</a:t>
                       </a:r>
                     </a:p>
                   </a:txBody>
@@ -15161,7 +15271,7 @@
                           <a:ea typeface="Arial"/>
                           <a:cs typeface="Arial"/>
                         </a:rPr>
-                        <a:t>3,102  (+848)</a:t>
+                        <a:t>3,285  (+1,327)</a:t>
                       </a:r>
                     </a:p>
                   </a:txBody>
@@ -15627,7 +15737,7 @@
                 <a:ea typeface="Arial"/>
                 <a:cs typeface="Arial"/>
               </a:rPr>
-              <a:t>Option A · Solar 7.0 kWp</a:t>
+              <a:t>Option A · Solar 8.5 kWp</a:t>
             </a:r>
           </a:p>
         </p:txBody>
@@ -15677,7 +15787,7 @@
                 <a:ea typeface="Consolas"/>
                 <a:cs typeface="Consolas"/>
               </a:rPr>
-              <a:t>Buy: 3.3 years</a:t>
+              <a:t>Buy: 3.4 years</a:t>
             </a:r>
           </a:p>
         </p:txBody>
@@ -15727,7 +15837,7 @@
                 <a:ea typeface="Consolas"/>
                 <a:cs typeface="Consolas"/>
               </a:rPr>
-              <a:t>Subscribe: 1,192 EGP/month for 8 years</a:t>
+              <a:t>Subscribe: 1,467 EGP/month for 8 years</a:t>
             </a:r>
           </a:p>
         </p:txBody>
@@ -15777,7 +15887,7 @@
                 <a:ea typeface="Arial"/>
                 <a:cs typeface="Arial"/>
               </a:rPr>
-              <a:t>Shop keeps 1,676 EGP a month from day one</a:t>
+              <a:t>Shop keeps 1,947 EGP a month from day one</a:t>
             </a:r>
           </a:p>
         </p:txBody>
@@ -15854,7 +15964,7 @@
         <p:spPr>
           <a:xfrm xmlns:a="http://schemas.openxmlformats.org/drawingml/2006/main">
             <a:off x="6451600" y="2514600"/>
-            <a:ext cx="4673600" cy="317500"/>
+            <a:ext cx="4673600" cy="329184"/>
           </a:xfrm>
           <a:prstGeom xmlns:a="http://schemas.openxmlformats.org/drawingml/2006/main" prst="rect">
             <a:avLst/>
@@ -15882,7 +15992,7 @@
                 <a:ea typeface="Arial"/>
                 <a:cs typeface="Arial"/>
               </a:rPr>
-              <a:t>Option B · Solar 10 kWp + LV_16</a:t>
+              <a:t>Option B · Solar 11.0 kWp + LV_16</a:t>
             </a:r>
           </a:p>
         </p:txBody>
@@ -15932,7 +16042,7 @@
                 <a:ea typeface="Consolas"/>
                 <a:cs typeface="Consolas"/>
               </a:rPr>
-              <a:t>Buy: 7.9 years</a:t>
+              <a:t>Buy: 7.1 years</a:t>
             </a:r>
           </a:p>
         </p:txBody>
@@ -15982,7 +16092,7 @@
                 <a:ea typeface="Consolas"/>
                 <a:cs typeface="Consolas"/>
               </a:rPr>
-              <a:t>Subscribe: 3,102 EGP/month for 10 years</a:t>
+              <a:t>Subscribe: 3,285 EGP/month for 10 years</a:t>
             </a:r>
           </a:p>
         </p:txBody>
@@ -16032,7 +16142,7 @@
                 <a:ea typeface="Arial"/>
                 <a:cs typeface="Arial"/>
               </a:rPr>
-              <a:t>Shop keeps 848 EGP a month and ≈ 7 h of refrigeration backup</a:t>
+              <a:t>Shop keeps 1,327 EGP a month and ≈ 7 h of refrigeration backup</a:t>
             </a:r>
           </a:p>
         </p:txBody>

</xml_diff>